<commit_message>
Align presentation text and make app fields responsive across devices
</commit_message>
<xml_diff>
--- a/presentation/Tech_It_and_Go_7_Minute_Presentation_With_Catalog_Link.pptx
+++ b/presentation/Tech_It_and_Go_7_Minute_Presentation_With_Catalog_Link.pptx
@@ -2,21 +2,21 @@
 <file path=ppt/presentation.xml><?xml version="1.0" encoding="utf-8"?>
 <p:presentation xmlns:p="http://schemas.openxmlformats.org/presentationml/2006/main">
   <p:sldMasterIdLst>
-    <p:sldMasterId xmlns:r="http://schemas.openxmlformats.org/officeDocument/2006/relationships" id="2147483648" r:id="R10f7b62162934d87"/>
+    <p:sldMasterId xmlns:r="http://schemas.openxmlformats.org/officeDocument/2006/relationships" id="2147483648" r:id="Re41407172c674d70"/>
   </p:sldMasterIdLst>
   <p:notesMasterIdLst>
-    <p:notesMasterId xmlns:r="http://schemas.openxmlformats.org/officeDocument/2006/relationships" r:id="R96782e94f5a74d61"/>
+    <p:notesMasterId xmlns:r="http://schemas.openxmlformats.org/officeDocument/2006/relationships" r:id="R4d1699e9585c4d31"/>
   </p:notesMasterIdLst>
   <p:sldIdLst>
-    <p:sldId xmlns:r="http://schemas.openxmlformats.org/officeDocument/2006/relationships" id="256" r:id="R74e01e135c7c4dc9"/>
-    <p:sldId xmlns:r="http://schemas.openxmlformats.org/officeDocument/2006/relationships" id="257" r:id="Rb04c63834c804959"/>
-    <p:sldId xmlns:r="http://schemas.openxmlformats.org/officeDocument/2006/relationships" id="258" r:id="Ra1b518047ef44ee5"/>
-    <p:sldId xmlns:r="http://schemas.openxmlformats.org/officeDocument/2006/relationships" id="259" r:id="Reee46c3f44174b79"/>
-    <p:sldId xmlns:r="http://schemas.openxmlformats.org/officeDocument/2006/relationships" id="260" r:id="Rdb839a4f47404146"/>
-    <p:sldId xmlns:r="http://schemas.openxmlformats.org/officeDocument/2006/relationships" id="261" r:id="R419ed2a19eca423e"/>
-    <p:sldId xmlns:r="http://schemas.openxmlformats.org/officeDocument/2006/relationships" id="262" r:id="Race99148d0b14467"/>
-    <p:sldId xmlns:r="http://schemas.openxmlformats.org/officeDocument/2006/relationships" id="263" r:id="R54d674a35a2442d5"/>
-    <p:sldId xmlns:r="http://schemas.openxmlformats.org/officeDocument/2006/relationships" id="264" r:id="Rccac4090ca914a13"/>
+    <p:sldId xmlns:r="http://schemas.openxmlformats.org/officeDocument/2006/relationships" id="256" r:id="R77e5e9cfc34246e5"/>
+    <p:sldId xmlns:r="http://schemas.openxmlformats.org/officeDocument/2006/relationships" id="257" r:id="R05b65b406c224eea"/>
+    <p:sldId xmlns:r="http://schemas.openxmlformats.org/officeDocument/2006/relationships" id="258" r:id="R2996e6a278e94cb2"/>
+    <p:sldId xmlns:r="http://schemas.openxmlformats.org/officeDocument/2006/relationships" id="259" r:id="Raf5d5cf83a864c3c"/>
+    <p:sldId xmlns:r="http://schemas.openxmlformats.org/officeDocument/2006/relationships" id="260" r:id="R2c7f505f08674495"/>
+    <p:sldId xmlns:r="http://schemas.openxmlformats.org/officeDocument/2006/relationships" id="261" r:id="R5cc4ab7c5c16414d"/>
+    <p:sldId xmlns:r="http://schemas.openxmlformats.org/officeDocument/2006/relationships" id="262" r:id="R0f080c304fd046a5"/>
+    <p:sldId xmlns:r="http://schemas.openxmlformats.org/officeDocument/2006/relationships" id="263" r:id="R46d5dda02bc547a3"/>
+    <p:sldId xmlns:r="http://schemas.openxmlformats.org/officeDocument/2006/relationships" id="264" r:id="Rb70a0a87daac4e34"/>
   </p:sldIdLst>
   <p:sldSz cx="12192000" cy="6858000"/>
   <p:notesSz cx="6858000" cy="9144000"/>
@@ -1498,8 +1498,8 @@
   </p:cSld>
   <p:clrMap bg1="lt1" tx1="dk1" bg2="lt2" tx2="dk2" accent1="accent1" accent2="accent2" accent3="accent3" accent4="accent4" accent5="accent5" accent6="accent6" hlink="hlink" folHlink="folHlink"/>
   <p:sldLayoutIdLst>
-    <p:sldLayoutId xmlns:r="http://schemas.openxmlformats.org/officeDocument/2006/relationships" id="2147483649" r:id="R78248124184c492d"/>
-    <p:sldLayoutId xmlns:r="http://schemas.openxmlformats.org/officeDocument/2006/relationships" id="2147483650" r:id="Rc6c11e65b9554aca"/>
+    <p:sldLayoutId xmlns:r="http://schemas.openxmlformats.org/officeDocument/2006/relationships" id="2147483649" r:id="R875d9e3c9d504cb7"/>
+    <p:sldLayoutId xmlns:r="http://schemas.openxmlformats.org/officeDocument/2006/relationships" id="2147483650" r:id="R3523107bcd154374"/>
   </p:sldLayoutIdLst>
   <p:hf sldNum="0" hdr="0" ftr="0" dt="0"/>
   <p:txStyles>
@@ -2070,7 +2070,7 @@
           <p:cNvPr id="2" name="Image 0">
             <a:extLst xmlns:a="http://schemas.openxmlformats.org/drawingml/2006/main">
               <a:ext uri="{FF2B5EF4-FFF2-40B4-BE49-F238E27FC236}">
-                <a16:creationId xmlns:a16="http://schemas.microsoft.com/office/drawing/2014/main" id="{E1D05532-3E61-46A1-A849-DF2FD11DE87F}"/>
+                <a16:creationId xmlns:a16="http://schemas.microsoft.com/office/drawing/2014/main" id="{79D0235C-47B4-46E2-8CDB-E343E673CAE5}"/>
               </a:ext>
             </a:extLst>
           </p:cNvPr>
@@ -2080,7 +2080,7 @@
           <p:nvPr/>
         </p:nvPicPr>
         <p:blipFill>
-          <a:blip xmlns:r="http://schemas.openxmlformats.org/officeDocument/2006/relationships" xmlns:a="http://schemas.openxmlformats.org/drawingml/2006/main" r:embed="R71d68e2595fa4170"/>
+          <a:blip xmlns:r="http://schemas.openxmlformats.org/officeDocument/2006/relationships" xmlns:a="http://schemas.openxmlformats.org/drawingml/2006/main" r:embed="R7e3c9e5e2bb54b1b"/>
           <a:srcRect xmlns:a="http://schemas.openxmlformats.org/drawingml/2006/main" l="0" t="0" r="0" b="0"/>
           <a:stretch xmlns:a="http://schemas.openxmlformats.org/drawingml/2006/main">
             <a:fillRect l="0" t="0" r="0" b="0"/>
@@ -2295,7 +2295,7 @@
           <p:cNvPr id="2" name="Image 0">
             <a:extLst xmlns:a="http://schemas.openxmlformats.org/drawingml/2006/main">
               <a:ext uri="{FF2B5EF4-FFF2-40B4-BE49-F238E27FC236}">
-                <a16:creationId xmlns:a16="http://schemas.microsoft.com/office/drawing/2014/main" id="{DDA8F684-9CB9-40A6-9B4B-3252A2E31127}"/>
+                <a16:creationId xmlns:a16="http://schemas.microsoft.com/office/drawing/2014/main" id="{D927EC7C-A732-471F-B9E4-347C7D655963}"/>
               </a:ext>
             </a:extLst>
           </p:cNvPr>
@@ -2305,7 +2305,7 @@
           <p:nvPr/>
         </p:nvPicPr>
         <p:blipFill>
-          <a:blip xmlns:r="http://schemas.openxmlformats.org/officeDocument/2006/relationships" xmlns:a="http://schemas.openxmlformats.org/drawingml/2006/main" r:embed="R8a4e44aa0af54d1d"/>
+          <a:blip xmlns:r="http://schemas.openxmlformats.org/officeDocument/2006/relationships" xmlns:a="http://schemas.openxmlformats.org/drawingml/2006/main" r:embed="R2784f0269c2c494e"/>
           <a:srcRect xmlns:a="http://schemas.openxmlformats.org/drawingml/2006/main" l="0" t="0" r="0" b="0"/>
           <a:stretch xmlns:a="http://schemas.openxmlformats.org/drawingml/2006/main">
             <a:fillRect l="0" t="0" r="0" b="0"/>
@@ -2346,7 +2346,9 @@
           <a:noFill xmlns:a="http://schemas.openxmlformats.org/drawingml/2006/main"/>
         </p:spPr>
         <p:txBody>
-          <a:bodyPr xmlns:a="http://schemas.openxmlformats.org/drawingml/2006/main" wrap="square" lIns="0" tIns="0" rIns="0" bIns="0" anchor="ctr"/>
+          <a:bodyPr xmlns:a="http://schemas.openxmlformats.org/drawingml/2006/main" wrap="square" lIns="0" tIns="0" rIns="0" bIns="0" anchor="ctr">
+            <a:normAutofit fontScale="100000"/>
+          </a:bodyPr>
           <a:lstStyle xmlns:a="http://schemas.openxmlformats.org/drawingml/2006/main"/>
           <a:p xmlns:a="http://schemas.openxmlformats.org/drawingml/2006/main">
             <a:pPr marL="0" indent="0">
@@ -2384,7 +2386,7 @@
         <p:spPr>
           <a:xfrm xmlns:a="http://schemas.openxmlformats.org/drawingml/2006/main">
             <a:off x="612648" y="987552"/>
-            <a:ext cx="10698480" cy="310896"/>
+            <a:ext cx="9655302" cy="310896"/>
           </a:xfrm>
           <a:prstGeom xmlns:a="http://schemas.openxmlformats.org/drawingml/2006/main" prst="rect">
             <a:avLst/>
@@ -2392,7 +2394,9 @@
           <a:noFill xmlns:a="http://schemas.openxmlformats.org/drawingml/2006/main"/>
         </p:spPr>
         <p:txBody>
-          <a:bodyPr xmlns:a="http://schemas.openxmlformats.org/drawingml/2006/main" wrap="square" lIns="0" tIns="0" rIns="0" bIns="0" anchor="ctr"/>
+          <a:bodyPr xmlns:a="http://schemas.openxmlformats.org/drawingml/2006/main" wrap="square" lIns="0" tIns="0" rIns="0" bIns="0" anchor="ctr">
+            <a:normAutofit fontScale="100000"/>
+          </a:bodyPr>
           <a:lstStyle xmlns:a="http://schemas.openxmlformats.org/drawingml/2006/main"/>
           <a:p xmlns:a="http://schemas.openxmlformats.org/drawingml/2006/main">
             <a:pPr marL="0" indent="0">
@@ -2514,12 +2518,14 @@
           <a:noFill xmlns:a="http://schemas.openxmlformats.org/drawingml/2006/main"/>
         </p:spPr>
         <p:txBody>
-          <a:bodyPr xmlns:a="http://schemas.openxmlformats.org/drawingml/2006/main" wrap="square" lIns="254" tIns="254" rIns="254" bIns="254" anchor="ctr">
-            <a:normAutofit/>
+          <a:bodyPr xmlns:a="http://schemas.openxmlformats.org/drawingml/2006/main" wrap="square" lIns="0" tIns="0" rIns="0" bIns="0" anchor="t">
+            <a:normAutofit fontScale="100000"/>
           </a:bodyPr>
-          <a:lstStyle xmlns:a="http://schemas.openxmlformats.org/drawingml/2006/main"/>
-          <a:p xmlns:a="http://schemas.openxmlformats.org/drawingml/2006/main">
-            <a:pPr marL="0" indent="0">
+          <a:lstStyle xmlns:a="http://schemas.openxmlformats.org/drawingml/2006/main">
+            <a:defPPr algn="l"/>
+          </a:lstStyle>
+          <a:p xmlns:a="http://schemas.openxmlformats.org/drawingml/2006/main">
+            <a:pPr marL="0" indent="0" algn="l">
               <a:buNone/>
             </a:pPr>
             <a:r>
@@ -2635,12 +2641,14 @@
           <a:noFill xmlns:a="http://schemas.openxmlformats.org/drawingml/2006/main"/>
         </p:spPr>
         <p:txBody>
-          <a:bodyPr xmlns:a="http://schemas.openxmlformats.org/drawingml/2006/main" wrap="square" lIns="254" tIns="254" rIns="254" bIns="254" anchor="ctr">
-            <a:normAutofit/>
+          <a:bodyPr xmlns:a="http://schemas.openxmlformats.org/drawingml/2006/main" wrap="square" lIns="0" tIns="0" rIns="0" bIns="0" anchor="t">
+            <a:normAutofit fontScale="100000"/>
           </a:bodyPr>
-          <a:lstStyle xmlns:a="http://schemas.openxmlformats.org/drawingml/2006/main"/>
-          <a:p xmlns:a="http://schemas.openxmlformats.org/drawingml/2006/main">
-            <a:pPr marL="0" indent="0">
+          <a:lstStyle xmlns:a="http://schemas.openxmlformats.org/drawingml/2006/main">
+            <a:defPPr algn="l"/>
+          </a:lstStyle>
+          <a:p xmlns:a="http://schemas.openxmlformats.org/drawingml/2006/main">
+            <a:pPr marL="0" indent="0" algn="l">
               <a:buNone/>
             </a:pPr>
             <a:r>
@@ -2807,7 +2815,7 @@
           <p:cNvPr id="2" name="Image 0">
             <a:extLst xmlns:a="http://schemas.openxmlformats.org/drawingml/2006/main">
               <a:ext uri="{FF2B5EF4-FFF2-40B4-BE49-F238E27FC236}">
-                <a16:creationId xmlns:a16="http://schemas.microsoft.com/office/drawing/2014/main" id="{1AE99E26-D365-43C7-8100-F48B75196AC4}"/>
+                <a16:creationId xmlns:a16="http://schemas.microsoft.com/office/drawing/2014/main" id="{CE4A63F3-FAE9-4852-9329-2E6125AEFA6C}"/>
               </a:ext>
             </a:extLst>
           </p:cNvPr>
@@ -2817,7 +2825,7 @@
           <p:nvPr/>
         </p:nvPicPr>
         <p:blipFill>
-          <a:blip xmlns:r="http://schemas.openxmlformats.org/officeDocument/2006/relationships" xmlns:a="http://schemas.openxmlformats.org/drawingml/2006/main" r:embed="R6ebd9f2823d749df"/>
+          <a:blip xmlns:r="http://schemas.openxmlformats.org/officeDocument/2006/relationships" xmlns:a="http://schemas.openxmlformats.org/drawingml/2006/main" r:embed="R6d84b29af2704571"/>
           <a:srcRect xmlns:a="http://schemas.openxmlformats.org/drawingml/2006/main" l="0" t="0" r="0" b="0"/>
           <a:stretch xmlns:a="http://schemas.openxmlformats.org/drawingml/2006/main">
             <a:fillRect l="0" t="0" r="0" b="0"/>
@@ -2858,7 +2866,9 @@
           <a:noFill xmlns:a="http://schemas.openxmlformats.org/drawingml/2006/main"/>
         </p:spPr>
         <p:txBody>
-          <a:bodyPr xmlns:a="http://schemas.openxmlformats.org/drawingml/2006/main" wrap="square" lIns="0" tIns="0" rIns="0" bIns="0" anchor="ctr"/>
+          <a:bodyPr xmlns:a="http://schemas.openxmlformats.org/drawingml/2006/main" wrap="square" lIns="0" tIns="0" rIns="0" bIns="0" anchor="ctr">
+            <a:normAutofit fontScale="100000"/>
+          </a:bodyPr>
           <a:lstStyle xmlns:a="http://schemas.openxmlformats.org/drawingml/2006/main"/>
           <a:p xmlns:a="http://schemas.openxmlformats.org/drawingml/2006/main">
             <a:pPr marL="0" indent="0">
@@ -2896,7 +2906,7 @@
         <p:spPr>
           <a:xfrm xmlns:a="http://schemas.openxmlformats.org/drawingml/2006/main">
             <a:off x="612648" y="987552"/>
-            <a:ext cx="10698480" cy="310896"/>
+            <a:ext cx="9655302" cy="310896"/>
           </a:xfrm>
           <a:prstGeom xmlns:a="http://schemas.openxmlformats.org/drawingml/2006/main" prst="rect">
             <a:avLst/>
@@ -2904,7 +2914,9 @@
           <a:noFill xmlns:a="http://schemas.openxmlformats.org/drawingml/2006/main"/>
         </p:spPr>
         <p:txBody>
-          <a:bodyPr xmlns:a="http://schemas.openxmlformats.org/drawingml/2006/main" wrap="square" lIns="0" tIns="0" rIns="0" bIns="0" anchor="ctr"/>
+          <a:bodyPr xmlns:a="http://schemas.openxmlformats.org/drawingml/2006/main" wrap="square" lIns="0" tIns="0" rIns="0" bIns="0" anchor="ctr">
+            <a:normAutofit fontScale="100000"/>
+          </a:bodyPr>
           <a:lstStyle xmlns:a="http://schemas.openxmlformats.org/drawingml/2006/main"/>
           <a:p xmlns:a="http://schemas.openxmlformats.org/drawingml/2006/main">
             <a:pPr marL="0" indent="0">
@@ -3026,12 +3038,14 @@
           <a:noFill xmlns:a="http://schemas.openxmlformats.org/drawingml/2006/main"/>
         </p:spPr>
         <p:txBody>
-          <a:bodyPr xmlns:a="http://schemas.openxmlformats.org/drawingml/2006/main" wrap="square" lIns="254" tIns="254" rIns="254" bIns="254" anchor="ctr">
-            <a:normAutofit/>
+          <a:bodyPr xmlns:a="http://schemas.openxmlformats.org/drawingml/2006/main" wrap="square" lIns="0" tIns="0" rIns="0" bIns="0" anchor="t">
+            <a:normAutofit fontScale="100000"/>
           </a:bodyPr>
-          <a:lstStyle xmlns:a="http://schemas.openxmlformats.org/drawingml/2006/main"/>
-          <a:p xmlns:a="http://schemas.openxmlformats.org/drawingml/2006/main">
-            <a:pPr marL="0" indent="0">
+          <a:lstStyle xmlns:a="http://schemas.openxmlformats.org/drawingml/2006/main">
+            <a:defPPr algn="l"/>
+          </a:lstStyle>
+          <a:p xmlns:a="http://schemas.openxmlformats.org/drawingml/2006/main">
+            <a:pPr marL="0" indent="0" algn="l">
               <a:buNone/>
             </a:pPr>
             <a:r>
@@ -3045,7 +3059,7 @@
             <a:endParaRPr sz="1700"/>
           </a:p>
           <a:p xmlns:a="http://schemas.openxmlformats.org/drawingml/2006/main">
-            <a:pPr marL="0" indent="0">
+            <a:pPr marL="0" indent="0" algn="l">
               <a:buNone/>
             </a:pPr>
             <a:r>
@@ -3059,7 +3073,7 @@
             <a:endParaRPr sz="1700"/>
           </a:p>
           <a:p xmlns:a="http://schemas.openxmlformats.org/drawingml/2006/main">
-            <a:pPr marL="0" indent="0">
+            <a:pPr marL="0" indent="0" algn="l">
               <a:buNone/>
             </a:pPr>
             <a:r>
@@ -3073,7 +3087,7 @@
             <a:endParaRPr sz="1700"/>
           </a:p>
           <a:p xmlns:a="http://schemas.openxmlformats.org/drawingml/2006/main">
-            <a:pPr marL="0" indent="0">
+            <a:pPr marL="0" indent="0" algn="l">
               <a:buNone/>
             </a:pPr>
             <a:r>
@@ -3189,12 +3203,14 @@
           <a:noFill xmlns:a="http://schemas.openxmlformats.org/drawingml/2006/main"/>
         </p:spPr>
         <p:txBody>
-          <a:bodyPr xmlns:a="http://schemas.openxmlformats.org/drawingml/2006/main" wrap="square" lIns="254" tIns="254" rIns="254" bIns="254" anchor="ctr">
-            <a:normAutofit/>
+          <a:bodyPr xmlns:a="http://schemas.openxmlformats.org/drawingml/2006/main" wrap="square" lIns="0" tIns="0" rIns="0" bIns="0" anchor="t">
+            <a:normAutofit fontScale="100000"/>
           </a:bodyPr>
-          <a:lstStyle xmlns:a="http://schemas.openxmlformats.org/drawingml/2006/main"/>
-          <a:p xmlns:a="http://schemas.openxmlformats.org/drawingml/2006/main">
-            <a:pPr marL="0" indent="0">
+          <a:lstStyle xmlns:a="http://schemas.openxmlformats.org/drawingml/2006/main">
+            <a:defPPr algn="l"/>
+          </a:lstStyle>
+          <a:p xmlns:a="http://schemas.openxmlformats.org/drawingml/2006/main">
+            <a:pPr marL="0" indent="0" algn="l">
               <a:buNone/>
             </a:pPr>
             <a:r>
@@ -3208,7 +3224,7 @@
             <a:endParaRPr sz="1700"/>
           </a:p>
           <a:p xmlns:a="http://schemas.openxmlformats.org/drawingml/2006/main">
-            <a:pPr marL="0" indent="0">
+            <a:pPr marL="0" indent="0" algn="l">
               <a:buNone/>
             </a:pPr>
             <a:r>
@@ -3222,7 +3238,7 @@
             <a:endParaRPr sz="1700"/>
           </a:p>
           <a:p xmlns:a="http://schemas.openxmlformats.org/drawingml/2006/main">
-            <a:pPr marL="0" indent="0">
+            <a:pPr marL="0" indent="0" algn="l">
               <a:buNone/>
             </a:pPr>
             <a:r>
@@ -3236,7 +3252,7 @@
             <a:endParaRPr sz="1700"/>
           </a:p>
           <a:p xmlns:a="http://schemas.openxmlformats.org/drawingml/2006/main">
-            <a:pPr marL="0" indent="0">
+            <a:pPr marL="0" indent="0" algn="l">
               <a:buNone/>
             </a:pPr>
             <a:r>
@@ -3327,7 +3343,7 @@
           <p:cNvPr id="2" name="Image 0">
             <a:extLst xmlns:a="http://schemas.openxmlformats.org/drawingml/2006/main">
               <a:ext uri="{FF2B5EF4-FFF2-40B4-BE49-F238E27FC236}">
-                <a16:creationId xmlns:a16="http://schemas.microsoft.com/office/drawing/2014/main" id="{4C665E4B-CE56-40D4-9928-2E3CCB2FE8AE}"/>
+                <a16:creationId xmlns:a16="http://schemas.microsoft.com/office/drawing/2014/main" id="{D9CC7D6F-E70A-466D-824A-851DCA53834C}"/>
               </a:ext>
             </a:extLst>
           </p:cNvPr>
@@ -3337,7 +3353,7 @@
           <p:nvPr/>
         </p:nvPicPr>
         <p:blipFill>
-          <a:blip xmlns:r="http://schemas.openxmlformats.org/officeDocument/2006/relationships" xmlns:a="http://schemas.openxmlformats.org/drawingml/2006/main" r:embed="Rdaef2cec51064e06"/>
+          <a:blip xmlns:r="http://schemas.openxmlformats.org/officeDocument/2006/relationships" xmlns:a="http://schemas.openxmlformats.org/drawingml/2006/main" r:embed="R1fe79742fd024d57"/>
           <a:srcRect xmlns:a="http://schemas.openxmlformats.org/drawingml/2006/main" l="0" t="0" r="0" b="0"/>
           <a:stretch xmlns:a="http://schemas.openxmlformats.org/drawingml/2006/main">
             <a:fillRect l="0" t="0" r="0" b="0"/>
@@ -3378,7 +3394,9 @@
           <a:noFill xmlns:a="http://schemas.openxmlformats.org/drawingml/2006/main"/>
         </p:spPr>
         <p:txBody>
-          <a:bodyPr xmlns:a="http://schemas.openxmlformats.org/drawingml/2006/main" wrap="square" lIns="0" tIns="0" rIns="0" bIns="0" anchor="ctr"/>
+          <a:bodyPr xmlns:a="http://schemas.openxmlformats.org/drawingml/2006/main" wrap="square" lIns="0" tIns="0" rIns="0" bIns="0" anchor="ctr">
+            <a:normAutofit fontScale="100000"/>
+          </a:bodyPr>
           <a:lstStyle xmlns:a="http://schemas.openxmlformats.org/drawingml/2006/main"/>
           <a:p xmlns:a="http://schemas.openxmlformats.org/drawingml/2006/main">
             <a:pPr marL="0" indent="0">
@@ -3416,7 +3434,7 @@
         <p:spPr>
           <a:xfrm xmlns:a="http://schemas.openxmlformats.org/drawingml/2006/main">
             <a:off x="612648" y="987552"/>
-            <a:ext cx="10698480" cy="310896"/>
+            <a:ext cx="9655302" cy="310896"/>
           </a:xfrm>
           <a:prstGeom xmlns:a="http://schemas.openxmlformats.org/drawingml/2006/main" prst="rect">
             <a:avLst/>
@@ -3424,7 +3442,9 @@
           <a:noFill xmlns:a="http://schemas.openxmlformats.org/drawingml/2006/main"/>
         </p:spPr>
         <p:txBody>
-          <a:bodyPr xmlns:a="http://schemas.openxmlformats.org/drawingml/2006/main" wrap="square" lIns="0" tIns="0" rIns="0" bIns="0" anchor="ctr"/>
+          <a:bodyPr xmlns:a="http://schemas.openxmlformats.org/drawingml/2006/main" wrap="square" lIns="0" tIns="0" rIns="0" bIns="0" anchor="ctr">
+            <a:normAutofit fontScale="100000"/>
+          </a:bodyPr>
           <a:lstStyle xmlns:a="http://schemas.openxmlformats.org/drawingml/2006/main"/>
           <a:p xmlns:a="http://schemas.openxmlformats.org/drawingml/2006/main">
             <a:pPr marL="0" indent="0">
@@ -3546,88 +3566,90 @@
           <a:noFill xmlns:a="http://schemas.openxmlformats.org/drawingml/2006/main"/>
         </p:spPr>
         <p:txBody>
-          <a:bodyPr xmlns:a="http://schemas.openxmlformats.org/drawingml/2006/main" wrap="square" lIns="254" tIns="254" rIns="254" bIns="254" anchor="ctr">
-            <a:normAutofit/>
+          <a:bodyPr xmlns:a="http://schemas.openxmlformats.org/drawingml/2006/main" wrap="square" lIns="0" tIns="0" rIns="0" bIns="0" anchor="t">
+            <a:normAutofit fontScale="100000"/>
           </a:bodyPr>
-          <a:lstStyle xmlns:a="http://schemas.openxmlformats.org/drawingml/2006/main"/>
+          <a:lstStyle xmlns:a="http://schemas.openxmlformats.org/drawingml/2006/main">
+            <a:defPPr algn="l"/>
+          </a:lstStyle>
+          <a:p xmlns:a="http://schemas.openxmlformats.org/drawingml/2006/main">
+            <a:pPr marL="0" indent="0" algn="l">
+              <a:buNone/>
+            </a:pPr>
+            <a:r>
+              <a:rPr sz="1700">
+                <a:solidFill>
+                  <a:srgbClr val="595465"/>
+                </a:solidFill>
+              </a:rPr>
+              <a:t>React + Vite</a:t>
+            </a:r>
+            <a:endParaRPr sz="1700"/>
+          </a:p>
+          <a:p xmlns:a="http://schemas.openxmlformats.org/drawingml/2006/main">
+            <a:pPr marL="0" indent="0" algn="l">
+              <a:buNone/>
+            </a:pPr>
+            <a:r>
+              <a:rPr sz="1700">
+                <a:solidFill>
+                  <a:srgbClr val="595465"/>
+                </a:solidFill>
+              </a:rPr>
+              <a:t>HTML/CSS concepts</a:t>
+            </a:r>
+            <a:endParaRPr sz="1700"/>
+          </a:p>
+          <a:p xmlns:a="http://schemas.openxmlformats.org/drawingml/2006/main">
+            <a:pPr marL="0" indent="0" algn="l">
+              <a:buNone/>
+            </a:pPr>
+            <a:r>
+              <a:rPr sz="1700">
+                <a:solidFill>
+                  <a:srgbClr val="595465"/>
+                </a:solidFill>
+              </a:rPr>
+              <a:t>JavaScript</a:t>
+            </a:r>
+            <a:endParaRPr sz="1700"/>
+          </a:p>
+          <a:p xmlns:a="http://schemas.openxmlformats.org/drawingml/2006/main">
+            <a:pPr marL="0" indent="0" algn="l">
+              <a:buNone/>
+            </a:pPr>
+            <a:r>
+              <a:rPr sz="1700">
+                <a:solidFill>
+                  <a:srgbClr val="595465"/>
+                </a:solidFill>
+              </a:rPr>
+              <a:t>React Router</a:t>
+            </a:r>
+            <a:endParaRPr sz="1700"/>
+          </a:p>
+          <a:p xmlns:a="http://schemas.openxmlformats.org/drawingml/2006/main">
+            <a:pPr marL="0" indent="0" algn="l">
+              <a:buNone/>
+            </a:pPr>
+            <a:r>
+              <a:rPr sz="1700">
+                <a:solidFill>
+                  <a:srgbClr val="595465"/>
+                </a:solidFill>
+              </a:rPr>
+              <a:t>Fetch API</a:t>
+            </a:r>
+            <a:endParaRPr sz="1700"/>
+          </a:p>
           <a:p xmlns:a="http://schemas.openxmlformats.org/drawingml/2006/main">
             <a:pPr marL="0" indent="0">
               <a:buNone/>
             </a:pPr>
-            <a:r>
-              <a:rPr sz="1700">
-                <a:solidFill>
-                  <a:srgbClr val="595465"/>
-                </a:solidFill>
-              </a:rPr>
-              <a:t>React + Vite</a:t>
-            </a:r>
             <a:endParaRPr sz="1700"/>
           </a:p>
           <a:p xmlns:a="http://schemas.openxmlformats.org/drawingml/2006/main">
-            <a:pPr marL="0" indent="0">
-              <a:buNone/>
-            </a:pPr>
-            <a:r>
-              <a:rPr sz="1700">
-                <a:solidFill>
-                  <a:srgbClr val="595465"/>
-                </a:solidFill>
-              </a:rPr>
-              <a:t>HTML/CSS concepts</a:t>
-            </a:r>
-            <a:endParaRPr sz="1700"/>
-          </a:p>
-          <a:p xmlns:a="http://schemas.openxmlformats.org/drawingml/2006/main">
-            <a:pPr marL="0" indent="0">
-              <a:buNone/>
-            </a:pPr>
-            <a:r>
-              <a:rPr sz="1700">
-                <a:solidFill>
-                  <a:srgbClr val="595465"/>
-                </a:solidFill>
-              </a:rPr>
-              <a:t>JavaScript</a:t>
-            </a:r>
-            <a:endParaRPr sz="1700"/>
-          </a:p>
-          <a:p xmlns:a="http://schemas.openxmlformats.org/drawingml/2006/main">
-            <a:pPr marL="0" indent="0">
-              <a:buNone/>
-            </a:pPr>
-            <a:r>
-              <a:rPr sz="1700">
-                <a:solidFill>
-                  <a:srgbClr val="595465"/>
-                </a:solidFill>
-              </a:rPr>
-              <a:t>React Router</a:t>
-            </a:r>
-            <a:endParaRPr sz="1700"/>
-          </a:p>
-          <a:p xmlns:a="http://schemas.openxmlformats.org/drawingml/2006/main">
-            <a:pPr marL="0" indent="0">
-              <a:buNone/>
-            </a:pPr>
-            <a:r>
-              <a:rPr sz="1700">
-                <a:solidFill>
-                  <a:srgbClr val="595465"/>
-                </a:solidFill>
-              </a:rPr>
-              <a:t>Fetch API</a:t>
-            </a:r>
-            <a:endParaRPr sz="1700"/>
-          </a:p>
-          <a:p xmlns:a="http://schemas.openxmlformats.org/drawingml/2006/main">
-            <a:pPr marL="0" indent="0">
-              <a:buNone/>
-            </a:pPr>
-            <a:endParaRPr sz="1700"/>
-          </a:p>
-          <a:p xmlns:a="http://schemas.openxmlformats.org/drawingml/2006/main">
-            <a:pPr marL="0" indent="0">
+            <a:pPr marL="0" indent="0" algn="l">
               <a:buNone/>
             </a:pPr>
             <a:r>
@@ -3743,88 +3765,90 @@
           <a:noFill xmlns:a="http://schemas.openxmlformats.org/drawingml/2006/main"/>
         </p:spPr>
         <p:txBody>
-          <a:bodyPr xmlns:a="http://schemas.openxmlformats.org/drawingml/2006/main" wrap="square" lIns="254" tIns="254" rIns="254" bIns="254" anchor="ctr">
-            <a:normAutofit/>
+          <a:bodyPr xmlns:a="http://schemas.openxmlformats.org/drawingml/2006/main" wrap="square" lIns="0" tIns="0" rIns="0" bIns="0" anchor="t">
+            <a:normAutofit fontScale="100000"/>
           </a:bodyPr>
-          <a:lstStyle xmlns:a="http://schemas.openxmlformats.org/drawingml/2006/main"/>
+          <a:lstStyle xmlns:a="http://schemas.openxmlformats.org/drawingml/2006/main">
+            <a:defPPr algn="l"/>
+          </a:lstStyle>
+          <a:p xmlns:a="http://schemas.openxmlformats.org/drawingml/2006/main">
+            <a:pPr marL="0" indent="0" algn="l">
+              <a:buNone/>
+            </a:pPr>
+            <a:r>
+              <a:rPr sz="1700">
+                <a:solidFill>
+                  <a:srgbClr val="595465"/>
+                </a:solidFill>
+              </a:rPr>
+              <a:t>Node.js</a:t>
+            </a:r>
+            <a:endParaRPr sz="1700"/>
+          </a:p>
+          <a:p xmlns:a="http://schemas.openxmlformats.org/drawingml/2006/main">
+            <a:pPr marL="0" indent="0" algn="l">
+              <a:buNone/>
+            </a:pPr>
+            <a:r>
+              <a:rPr sz="1700">
+                <a:solidFill>
+                  <a:srgbClr val="595465"/>
+                </a:solidFill>
+              </a:rPr>
+              <a:t>Express.js</a:t>
+            </a:r>
+            <a:endParaRPr sz="1700"/>
+          </a:p>
+          <a:p xmlns:a="http://schemas.openxmlformats.org/drawingml/2006/main">
+            <a:pPr marL="0" indent="0" algn="l">
+              <a:buNone/>
+            </a:pPr>
+            <a:r>
+              <a:rPr sz="1700">
+                <a:solidFill>
+                  <a:srgbClr val="595465"/>
+                </a:solidFill>
+              </a:rPr>
+              <a:t>REST API</a:t>
+            </a:r>
+            <a:endParaRPr sz="1700"/>
+          </a:p>
+          <a:p xmlns:a="http://schemas.openxmlformats.org/drawingml/2006/main">
+            <a:pPr marL="0" indent="0" algn="l">
+              <a:buNone/>
+            </a:pPr>
+            <a:r>
+              <a:rPr sz="1700">
+                <a:solidFill>
+                  <a:srgbClr val="595465"/>
+                </a:solidFill>
+              </a:rPr>
+              <a:t>Middleware</a:t>
+            </a:r>
+            <a:endParaRPr sz="1700"/>
+          </a:p>
+          <a:p xmlns:a="http://schemas.openxmlformats.org/drawingml/2006/main">
+            <a:pPr marL="0" indent="0" algn="l">
+              <a:buNone/>
+            </a:pPr>
+            <a:r>
+              <a:rPr sz="1700">
+                <a:solidFill>
+                  <a:srgbClr val="595465"/>
+                </a:solidFill>
+              </a:rPr>
+              <a:t>CORS + dotenv</a:t>
+            </a:r>
+            <a:endParaRPr sz="1700"/>
+          </a:p>
           <a:p xmlns:a="http://schemas.openxmlformats.org/drawingml/2006/main">
             <a:pPr marL="0" indent="0">
               <a:buNone/>
             </a:pPr>
-            <a:r>
-              <a:rPr sz="1700">
-                <a:solidFill>
-                  <a:srgbClr val="595465"/>
-                </a:solidFill>
-              </a:rPr>
-              <a:t>Node.js</a:t>
-            </a:r>
             <a:endParaRPr sz="1700"/>
           </a:p>
           <a:p xmlns:a="http://schemas.openxmlformats.org/drawingml/2006/main">
-            <a:pPr marL="0" indent="0">
-              <a:buNone/>
-            </a:pPr>
-            <a:r>
-              <a:rPr sz="1700">
-                <a:solidFill>
-                  <a:srgbClr val="595465"/>
-                </a:solidFill>
-              </a:rPr>
-              <a:t>Express.js</a:t>
-            </a:r>
-            <a:endParaRPr sz="1700"/>
-          </a:p>
-          <a:p xmlns:a="http://schemas.openxmlformats.org/drawingml/2006/main">
-            <a:pPr marL="0" indent="0">
-              <a:buNone/>
-            </a:pPr>
-            <a:r>
-              <a:rPr sz="1700">
-                <a:solidFill>
-                  <a:srgbClr val="595465"/>
-                </a:solidFill>
-              </a:rPr>
-              <a:t>REST API</a:t>
-            </a:r>
-            <a:endParaRPr sz="1700"/>
-          </a:p>
-          <a:p xmlns:a="http://schemas.openxmlformats.org/drawingml/2006/main">
-            <a:pPr marL="0" indent="0">
-              <a:buNone/>
-            </a:pPr>
-            <a:r>
-              <a:rPr sz="1700">
-                <a:solidFill>
-                  <a:srgbClr val="595465"/>
-                </a:solidFill>
-              </a:rPr>
-              <a:t>Middleware</a:t>
-            </a:r>
-            <a:endParaRPr sz="1700"/>
-          </a:p>
-          <a:p xmlns:a="http://schemas.openxmlformats.org/drawingml/2006/main">
-            <a:pPr marL="0" indent="0">
-              <a:buNone/>
-            </a:pPr>
-            <a:r>
-              <a:rPr sz="1700">
-                <a:solidFill>
-                  <a:srgbClr val="595465"/>
-                </a:solidFill>
-              </a:rPr>
-              <a:t>CORS + dotenv</a:t>
-            </a:r>
-            <a:endParaRPr sz="1700"/>
-          </a:p>
-          <a:p xmlns:a="http://schemas.openxmlformats.org/drawingml/2006/main">
-            <a:pPr marL="0" indent="0">
-              <a:buNone/>
-            </a:pPr>
-            <a:endParaRPr sz="1700"/>
-          </a:p>
-          <a:p xmlns:a="http://schemas.openxmlformats.org/drawingml/2006/main">
-            <a:pPr marL="0" indent="0">
+            <a:pPr marL="0" indent="0" algn="l">
               <a:buNone/>
             </a:pPr>
             <a:r>
@@ -3940,60 +3964,62 @@
           <a:noFill xmlns:a="http://schemas.openxmlformats.org/drawingml/2006/main"/>
         </p:spPr>
         <p:txBody>
-          <a:bodyPr xmlns:a="http://schemas.openxmlformats.org/drawingml/2006/main" wrap="square" lIns="254" tIns="254" rIns="254" bIns="254" anchor="ctr">
-            <a:normAutofit/>
+          <a:bodyPr xmlns:a="http://schemas.openxmlformats.org/drawingml/2006/main" wrap="square" lIns="0" tIns="0" rIns="0" bIns="0" anchor="t">
+            <a:normAutofit fontScale="100000"/>
           </a:bodyPr>
-          <a:lstStyle xmlns:a="http://schemas.openxmlformats.org/drawingml/2006/main"/>
+          <a:lstStyle xmlns:a="http://schemas.openxmlformats.org/drawingml/2006/main">
+            <a:defPPr algn="l"/>
+          </a:lstStyle>
+          <a:p xmlns:a="http://schemas.openxmlformats.org/drawingml/2006/main">
+            <a:pPr marL="0" indent="0" algn="l">
+              <a:buNone/>
+            </a:pPr>
+            <a:r>
+              <a:rPr sz="1700">
+                <a:solidFill>
+                  <a:srgbClr val="595465"/>
+                </a:solidFill>
+              </a:rPr>
+              <a:t>MongoDB Atlas</a:t>
+            </a:r>
+            <a:endParaRPr sz="1700"/>
+          </a:p>
+          <a:p xmlns:a="http://schemas.openxmlformats.org/drawingml/2006/main">
+            <a:pPr marL="0" indent="0" algn="l">
+              <a:buNone/>
+            </a:pPr>
+            <a:r>
+              <a:rPr sz="1700">
+                <a:solidFill>
+                  <a:srgbClr val="595465"/>
+                </a:solidFill>
+              </a:rPr>
+              <a:t>Mongoose</a:t>
+            </a:r>
+            <a:endParaRPr sz="1700"/>
+          </a:p>
+          <a:p xmlns:a="http://schemas.openxmlformats.org/drawingml/2006/main">
+            <a:pPr marL="0" indent="0" algn="l">
+              <a:buNone/>
+            </a:pPr>
+            <a:r>
+              <a:rPr sz="1700">
+                <a:solidFill>
+                  <a:srgbClr val="595465"/>
+                </a:solidFill>
+              </a:rPr>
+              <a:t>Models + validation</a:t>
+            </a:r>
+            <a:endParaRPr sz="1700"/>
+          </a:p>
           <a:p xmlns:a="http://schemas.openxmlformats.org/drawingml/2006/main">
             <a:pPr marL="0" indent="0">
               <a:buNone/>
             </a:pPr>
-            <a:r>
-              <a:rPr sz="1700">
-                <a:solidFill>
-                  <a:srgbClr val="595465"/>
-                </a:solidFill>
-              </a:rPr>
-              <a:t>MongoDB Atlas</a:t>
-            </a:r>
             <a:endParaRPr sz="1700"/>
           </a:p>
           <a:p xmlns:a="http://schemas.openxmlformats.org/drawingml/2006/main">
-            <a:pPr marL="0" indent="0">
-              <a:buNone/>
-            </a:pPr>
-            <a:r>
-              <a:rPr sz="1700">
-                <a:solidFill>
-                  <a:srgbClr val="595465"/>
-                </a:solidFill>
-              </a:rPr>
-              <a:t>Mongoose</a:t>
-            </a:r>
-            <a:endParaRPr sz="1700"/>
-          </a:p>
-          <a:p xmlns:a="http://schemas.openxmlformats.org/drawingml/2006/main">
-            <a:pPr marL="0" indent="0">
-              <a:buNone/>
-            </a:pPr>
-            <a:r>
-              <a:rPr sz="1700">
-                <a:solidFill>
-                  <a:srgbClr val="595465"/>
-                </a:solidFill>
-              </a:rPr>
-              <a:t>Models + validation</a:t>
-            </a:r>
-            <a:endParaRPr sz="1700"/>
-          </a:p>
-          <a:p xmlns:a="http://schemas.openxmlformats.org/drawingml/2006/main">
-            <a:pPr marL="0" indent="0">
-              <a:buNone/>
-            </a:pPr>
-            <a:endParaRPr sz="1700"/>
-          </a:p>
-          <a:p xmlns:a="http://schemas.openxmlformats.org/drawingml/2006/main">
-            <a:pPr marL="0" indent="0">
+            <a:pPr marL="0" indent="0" algn="l">
               <a:buNone/>
             </a:pPr>
             <a:r>
@@ -4084,7 +4110,7 @@
           <p:cNvPr id="2" name="Image 0">
             <a:extLst xmlns:a="http://schemas.openxmlformats.org/drawingml/2006/main">
               <a:ext uri="{FF2B5EF4-FFF2-40B4-BE49-F238E27FC236}">
-                <a16:creationId xmlns:a16="http://schemas.microsoft.com/office/drawing/2014/main" id="{64FFC96D-9106-47EB-A2F8-BE412C860197}"/>
+                <a16:creationId xmlns:a16="http://schemas.microsoft.com/office/drawing/2014/main" id="{17010C04-7F72-4A39-B941-75A99F297A0B}"/>
               </a:ext>
             </a:extLst>
           </p:cNvPr>
@@ -4094,7 +4120,7 @@
           <p:nvPr/>
         </p:nvPicPr>
         <p:blipFill>
-          <a:blip xmlns:r="http://schemas.openxmlformats.org/officeDocument/2006/relationships" xmlns:a="http://schemas.openxmlformats.org/drawingml/2006/main" r:embed="Ra10d05501d2740a3"/>
+          <a:blip xmlns:r="http://schemas.openxmlformats.org/officeDocument/2006/relationships" xmlns:a="http://schemas.openxmlformats.org/drawingml/2006/main" r:embed="Rf3b3a36f0c1142c6"/>
           <a:srcRect xmlns:a="http://schemas.openxmlformats.org/drawingml/2006/main" l="0" t="0" r="0" b="0"/>
           <a:stretch xmlns:a="http://schemas.openxmlformats.org/drawingml/2006/main">
             <a:fillRect l="0" t="0" r="0" b="0"/>
@@ -4135,7 +4161,9 @@
           <a:noFill xmlns:a="http://schemas.openxmlformats.org/drawingml/2006/main"/>
         </p:spPr>
         <p:txBody>
-          <a:bodyPr xmlns:a="http://schemas.openxmlformats.org/drawingml/2006/main" wrap="square" lIns="0" tIns="0" rIns="0" bIns="0" anchor="ctr"/>
+          <a:bodyPr xmlns:a="http://schemas.openxmlformats.org/drawingml/2006/main" wrap="square" lIns="0" tIns="0" rIns="0" bIns="0" anchor="ctr">
+            <a:normAutofit fontScale="100000"/>
+          </a:bodyPr>
           <a:lstStyle xmlns:a="http://schemas.openxmlformats.org/drawingml/2006/main"/>
           <a:p xmlns:a="http://schemas.openxmlformats.org/drawingml/2006/main">
             <a:pPr marL="0" indent="0">
@@ -4173,7 +4201,7 @@
         <p:spPr>
           <a:xfrm xmlns:a="http://schemas.openxmlformats.org/drawingml/2006/main">
             <a:off x="612648" y="987552"/>
-            <a:ext cx="10698480" cy="310896"/>
+            <a:ext cx="9655302" cy="310896"/>
           </a:xfrm>
           <a:prstGeom xmlns:a="http://schemas.openxmlformats.org/drawingml/2006/main" prst="rect">
             <a:avLst/>
@@ -4181,7 +4209,9 @@
           <a:noFill xmlns:a="http://schemas.openxmlformats.org/drawingml/2006/main"/>
         </p:spPr>
         <p:txBody>
-          <a:bodyPr xmlns:a="http://schemas.openxmlformats.org/drawingml/2006/main" wrap="square" lIns="0" tIns="0" rIns="0" bIns="0" anchor="ctr"/>
+          <a:bodyPr xmlns:a="http://schemas.openxmlformats.org/drawingml/2006/main" wrap="square" lIns="0" tIns="0" rIns="0" bIns="0" anchor="ctr">
+            <a:normAutofit fontScale="100000"/>
+          </a:bodyPr>
           <a:lstStyle xmlns:a="http://schemas.openxmlformats.org/drawingml/2006/main"/>
           <a:p xmlns:a="http://schemas.openxmlformats.org/drawingml/2006/main">
             <a:pPr marL="0" indent="0">
@@ -4303,12 +4333,14 @@
           <a:noFill xmlns:a="http://schemas.openxmlformats.org/drawingml/2006/main"/>
         </p:spPr>
         <p:txBody>
-          <a:bodyPr xmlns:a="http://schemas.openxmlformats.org/drawingml/2006/main" wrap="square" lIns="254" tIns="254" rIns="254" bIns="254" anchor="ctr">
-            <a:normAutofit/>
+          <a:bodyPr xmlns:a="http://schemas.openxmlformats.org/drawingml/2006/main" wrap="square" lIns="0" tIns="0" rIns="0" bIns="0" anchor="t">
+            <a:normAutofit fontScale="100000"/>
           </a:bodyPr>
-          <a:lstStyle xmlns:a="http://schemas.openxmlformats.org/drawingml/2006/main"/>
-          <a:p xmlns:a="http://schemas.openxmlformats.org/drawingml/2006/main">
-            <a:pPr marL="0" indent="0">
+          <a:lstStyle xmlns:a="http://schemas.openxmlformats.org/drawingml/2006/main">
+            <a:defPPr algn="l"/>
+          </a:lstStyle>
+          <a:p xmlns:a="http://schemas.openxmlformats.org/drawingml/2006/main">
+            <a:pPr marL="0" indent="0" algn="l">
               <a:buNone/>
             </a:pPr>
             <a:r>
@@ -4322,7 +4354,7 @@
             <a:endParaRPr sz="1700"/>
           </a:p>
           <a:p xmlns:a="http://schemas.openxmlformats.org/drawingml/2006/main">
-            <a:pPr marL="0" indent="0">
+            <a:pPr marL="0" indent="0" algn="l">
               <a:buNone/>
             </a:pPr>
             <a:r>
@@ -4438,12 +4470,14 @@
           <a:noFill xmlns:a="http://schemas.openxmlformats.org/drawingml/2006/main"/>
         </p:spPr>
         <p:txBody>
-          <a:bodyPr xmlns:a="http://schemas.openxmlformats.org/drawingml/2006/main" wrap="square" lIns="254" tIns="254" rIns="254" bIns="254" anchor="ctr">
-            <a:normAutofit/>
+          <a:bodyPr xmlns:a="http://schemas.openxmlformats.org/drawingml/2006/main" wrap="square" lIns="0" tIns="0" rIns="0" bIns="0" anchor="t">
+            <a:normAutofit fontScale="100000"/>
           </a:bodyPr>
-          <a:lstStyle xmlns:a="http://schemas.openxmlformats.org/drawingml/2006/main"/>
-          <a:p xmlns:a="http://schemas.openxmlformats.org/drawingml/2006/main">
-            <a:pPr marL="0" indent="0">
+          <a:lstStyle xmlns:a="http://schemas.openxmlformats.org/drawingml/2006/main">
+            <a:defPPr algn="l"/>
+          </a:lstStyle>
+          <a:p xmlns:a="http://schemas.openxmlformats.org/drawingml/2006/main">
+            <a:pPr marL="0" indent="0" algn="l">
               <a:buNone/>
             </a:pPr>
             <a:r>
@@ -4457,7 +4491,7 @@
             <a:endParaRPr sz="1700"/>
           </a:p>
           <a:p xmlns:a="http://schemas.openxmlformats.org/drawingml/2006/main">
-            <a:pPr marL="0" indent="0">
+            <a:pPr marL="0" indent="0" algn="l">
               <a:buNone/>
             </a:pPr>
             <a:r>
@@ -4573,12 +4607,14 @@
           <a:noFill xmlns:a="http://schemas.openxmlformats.org/drawingml/2006/main"/>
         </p:spPr>
         <p:txBody>
-          <a:bodyPr xmlns:a="http://schemas.openxmlformats.org/drawingml/2006/main" wrap="square" lIns="254" tIns="254" rIns="254" bIns="254" anchor="ctr">
-            <a:normAutofit/>
+          <a:bodyPr xmlns:a="http://schemas.openxmlformats.org/drawingml/2006/main" wrap="square" lIns="0" tIns="0" rIns="0" bIns="0" anchor="t">
+            <a:normAutofit fontScale="100000"/>
           </a:bodyPr>
-          <a:lstStyle xmlns:a="http://schemas.openxmlformats.org/drawingml/2006/main"/>
-          <a:p xmlns:a="http://schemas.openxmlformats.org/drawingml/2006/main">
-            <a:pPr marL="0" indent="0">
+          <a:lstStyle xmlns:a="http://schemas.openxmlformats.org/drawingml/2006/main">
+            <a:defPPr algn="l"/>
+          </a:lstStyle>
+          <a:p xmlns:a="http://schemas.openxmlformats.org/drawingml/2006/main">
+            <a:pPr marL="0" indent="0" algn="l">
               <a:buNone/>
             </a:pPr>
             <a:r>
@@ -4592,7 +4628,7 @@
             <a:endParaRPr sz="1700"/>
           </a:p>
           <a:p xmlns:a="http://schemas.openxmlformats.org/drawingml/2006/main">
-            <a:pPr marL="0" indent="0">
+            <a:pPr marL="0" indent="0" algn="l">
               <a:buNone/>
             </a:pPr>
             <a:r>
@@ -4708,12 +4744,14 @@
           <a:noFill xmlns:a="http://schemas.openxmlformats.org/drawingml/2006/main"/>
         </p:spPr>
         <p:txBody>
-          <a:bodyPr xmlns:a="http://schemas.openxmlformats.org/drawingml/2006/main" wrap="square" lIns="254" tIns="254" rIns="254" bIns="254" anchor="ctr">
-            <a:normAutofit/>
+          <a:bodyPr xmlns:a="http://schemas.openxmlformats.org/drawingml/2006/main" wrap="square" lIns="0" tIns="0" rIns="0" bIns="0" anchor="t">
+            <a:normAutofit fontScale="100000"/>
           </a:bodyPr>
-          <a:lstStyle xmlns:a="http://schemas.openxmlformats.org/drawingml/2006/main"/>
-          <a:p xmlns:a="http://schemas.openxmlformats.org/drawingml/2006/main">
-            <a:pPr marL="0" indent="0">
+          <a:lstStyle xmlns:a="http://schemas.openxmlformats.org/drawingml/2006/main">
+            <a:defPPr algn="l"/>
+          </a:lstStyle>
+          <a:p xmlns:a="http://schemas.openxmlformats.org/drawingml/2006/main">
+            <a:pPr marL="0" indent="0" algn="l">
               <a:buNone/>
             </a:pPr>
             <a:r>
@@ -4727,7 +4765,7 @@
             <a:endParaRPr sz="1700"/>
           </a:p>
           <a:p xmlns:a="http://schemas.openxmlformats.org/drawingml/2006/main">
-            <a:pPr marL="0" indent="0">
+            <a:pPr marL="0" indent="0" algn="l">
               <a:buNone/>
             </a:pPr>
             <a:r>
@@ -4894,7 +4932,7 @@
           <p:cNvPr id="2" name="Image 0">
             <a:extLst xmlns:a="http://schemas.openxmlformats.org/drawingml/2006/main">
               <a:ext uri="{FF2B5EF4-FFF2-40B4-BE49-F238E27FC236}">
-                <a16:creationId xmlns:a16="http://schemas.microsoft.com/office/drawing/2014/main" id="{1E3F8663-4A9F-4999-9B93-1D724BC2BEB8}"/>
+                <a16:creationId xmlns:a16="http://schemas.microsoft.com/office/drawing/2014/main" id="{0CDA8B9F-5707-412A-951B-D82E1EAD8DE3}"/>
               </a:ext>
             </a:extLst>
           </p:cNvPr>
@@ -4904,7 +4942,7 @@
           <p:nvPr/>
         </p:nvPicPr>
         <p:blipFill>
-          <a:blip xmlns:r="http://schemas.openxmlformats.org/officeDocument/2006/relationships" xmlns:a="http://schemas.openxmlformats.org/drawingml/2006/main" r:embed="R3d666ab560d44e69"/>
+          <a:blip xmlns:r="http://schemas.openxmlformats.org/officeDocument/2006/relationships" xmlns:a="http://schemas.openxmlformats.org/drawingml/2006/main" r:embed="Rae59494ff7f5446d"/>
           <a:srcRect xmlns:a="http://schemas.openxmlformats.org/drawingml/2006/main" l="0" t="0" r="0" b="0"/>
           <a:stretch xmlns:a="http://schemas.openxmlformats.org/drawingml/2006/main">
             <a:fillRect l="0" t="0" r="0" b="0"/>
@@ -4945,7 +4983,9 @@
           <a:noFill xmlns:a="http://schemas.openxmlformats.org/drawingml/2006/main"/>
         </p:spPr>
         <p:txBody>
-          <a:bodyPr xmlns:a="http://schemas.openxmlformats.org/drawingml/2006/main" wrap="square" lIns="0" tIns="0" rIns="0" bIns="0" anchor="ctr"/>
+          <a:bodyPr xmlns:a="http://schemas.openxmlformats.org/drawingml/2006/main" wrap="square" lIns="0" tIns="0" rIns="0" bIns="0" anchor="ctr">
+            <a:normAutofit fontScale="100000"/>
+          </a:bodyPr>
           <a:lstStyle xmlns:a="http://schemas.openxmlformats.org/drawingml/2006/main"/>
           <a:p xmlns:a="http://schemas.openxmlformats.org/drawingml/2006/main">
             <a:pPr marL="0" indent="0">
@@ -4983,7 +5023,7 @@
         <p:spPr>
           <a:xfrm xmlns:a="http://schemas.openxmlformats.org/drawingml/2006/main">
             <a:off x="612648" y="987552"/>
-            <a:ext cx="10698480" cy="310896"/>
+            <a:ext cx="9655302" cy="310896"/>
           </a:xfrm>
           <a:prstGeom xmlns:a="http://schemas.openxmlformats.org/drawingml/2006/main" prst="rect">
             <a:avLst/>
@@ -4991,7 +5031,9 @@
           <a:noFill xmlns:a="http://schemas.openxmlformats.org/drawingml/2006/main"/>
         </p:spPr>
         <p:txBody>
-          <a:bodyPr xmlns:a="http://schemas.openxmlformats.org/drawingml/2006/main" wrap="square" lIns="0" tIns="0" rIns="0" bIns="0" anchor="ctr"/>
+          <a:bodyPr xmlns:a="http://schemas.openxmlformats.org/drawingml/2006/main" wrap="square" lIns="0" tIns="0" rIns="0" bIns="0" anchor="ctr">
+            <a:normAutofit fontScale="100000"/>
+          </a:bodyPr>
           <a:lstStyle xmlns:a="http://schemas.openxmlformats.org/drawingml/2006/main"/>
           <a:p xmlns:a="http://schemas.openxmlformats.org/drawingml/2006/main">
             <a:pPr marL="0" indent="0">
@@ -5113,12 +5155,14 @@
           <a:noFill xmlns:a="http://schemas.openxmlformats.org/drawingml/2006/main"/>
         </p:spPr>
         <p:txBody>
-          <a:bodyPr xmlns:a="http://schemas.openxmlformats.org/drawingml/2006/main" wrap="square" lIns="254" tIns="254" rIns="254" bIns="254" anchor="ctr">
-            <a:normAutofit/>
+          <a:bodyPr xmlns:a="http://schemas.openxmlformats.org/drawingml/2006/main" wrap="square" lIns="0" tIns="0" rIns="0" bIns="0" anchor="t">
+            <a:normAutofit fontScale="100000"/>
           </a:bodyPr>
-          <a:lstStyle xmlns:a="http://schemas.openxmlformats.org/drawingml/2006/main"/>
-          <a:p xmlns:a="http://schemas.openxmlformats.org/drawingml/2006/main">
-            <a:pPr marL="0" indent="0">
+          <a:lstStyle xmlns:a="http://schemas.openxmlformats.org/drawingml/2006/main">
+            <a:defPPr algn="l"/>
+          </a:lstStyle>
+          <a:p xmlns:a="http://schemas.openxmlformats.org/drawingml/2006/main">
+            <a:pPr marL="0" indent="0" algn="l">
               <a:buNone/>
             </a:pPr>
             <a:r>
@@ -5132,7 +5176,7 @@
             <a:endParaRPr sz="1700"/>
           </a:p>
           <a:p xmlns:a="http://schemas.openxmlformats.org/drawingml/2006/main">
-            <a:pPr marL="0" indent="0">
+            <a:pPr marL="0" indent="0" algn="l">
               <a:buNone/>
             </a:pPr>
             <a:r>
@@ -5146,7 +5190,7 @@
             <a:endParaRPr sz="1700"/>
           </a:p>
           <a:p xmlns:a="http://schemas.openxmlformats.org/drawingml/2006/main">
-            <a:pPr marL="0" indent="0">
+            <a:pPr marL="0" indent="0" algn="l">
               <a:buNone/>
             </a:pPr>
             <a:r>
@@ -5160,7 +5204,7 @@
             <a:endParaRPr sz="1700"/>
           </a:p>
           <a:p xmlns:a="http://schemas.openxmlformats.org/drawingml/2006/main">
-            <a:pPr marL="0" indent="0">
+            <a:pPr marL="0" indent="0" algn="l">
               <a:buNone/>
             </a:pPr>
             <a:r>
@@ -5174,7 +5218,7 @@
             <a:endParaRPr sz="1700"/>
           </a:p>
           <a:p xmlns:a="http://schemas.openxmlformats.org/drawingml/2006/main">
-            <a:pPr marL="0" indent="0">
+            <a:pPr marL="0" indent="0" algn="l">
               <a:buNone/>
             </a:pPr>
             <a:r>
@@ -5188,7 +5232,7 @@
             <a:endParaRPr sz="1700"/>
           </a:p>
           <a:p xmlns:a="http://schemas.openxmlformats.org/drawingml/2006/main">
-            <a:pPr marL="0" indent="0">
+            <a:pPr marL="0" indent="0" algn="l">
               <a:buNone/>
             </a:pPr>
             <a:r>
@@ -5304,12 +5348,14 @@
           <a:noFill xmlns:a="http://schemas.openxmlformats.org/drawingml/2006/main"/>
         </p:spPr>
         <p:txBody>
-          <a:bodyPr xmlns:a="http://schemas.openxmlformats.org/drawingml/2006/main" wrap="square" lIns="254" tIns="254" rIns="254" bIns="254" anchor="ctr">
-            <a:normAutofit/>
+          <a:bodyPr xmlns:a="http://schemas.openxmlformats.org/drawingml/2006/main" wrap="square" lIns="0" tIns="0" rIns="0" bIns="0" anchor="t">
+            <a:normAutofit fontScale="100000"/>
           </a:bodyPr>
-          <a:lstStyle xmlns:a="http://schemas.openxmlformats.org/drawingml/2006/main"/>
-          <a:p xmlns:a="http://schemas.openxmlformats.org/drawingml/2006/main">
-            <a:pPr marL="0" indent="0">
+          <a:lstStyle xmlns:a="http://schemas.openxmlformats.org/drawingml/2006/main">
+            <a:defPPr algn="l"/>
+          </a:lstStyle>
+          <a:p xmlns:a="http://schemas.openxmlformats.org/drawingml/2006/main">
+            <a:pPr marL="0" indent="0" algn="l">
               <a:buNone/>
             </a:pPr>
             <a:r>
@@ -5323,7 +5369,7 @@
             <a:endParaRPr sz="1700"/>
           </a:p>
           <a:p xmlns:a="http://schemas.openxmlformats.org/drawingml/2006/main">
-            <a:pPr marL="0" indent="0">
+            <a:pPr marL="0" indent="0" algn="l">
               <a:buNone/>
             </a:pPr>
             <a:r>
@@ -5337,7 +5383,7 @@
             <a:endParaRPr sz="1700"/>
           </a:p>
           <a:p xmlns:a="http://schemas.openxmlformats.org/drawingml/2006/main">
-            <a:pPr marL="0" indent="0">
+            <a:pPr marL="0" indent="0" algn="l">
               <a:buNone/>
             </a:pPr>
             <a:r>
@@ -5351,7 +5397,7 @@
             <a:endParaRPr sz="1700"/>
           </a:p>
           <a:p xmlns:a="http://schemas.openxmlformats.org/drawingml/2006/main">
-            <a:pPr marL="0" indent="0">
+            <a:pPr marL="0" indent="0" algn="l">
               <a:buNone/>
             </a:pPr>
             <a:r>
@@ -5365,7 +5411,7 @@
             <a:endParaRPr sz="1700"/>
           </a:p>
           <a:p xmlns:a="http://schemas.openxmlformats.org/drawingml/2006/main">
-            <a:pPr marL="0" indent="0">
+            <a:pPr marL="0" indent="0" algn="l">
               <a:buNone/>
             </a:pPr>
             <a:r>
@@ -5379,7 +5425,7 @@
             <a:endParaRPr sz="1700"/>
           </a:p>
           <a:p xmlns:a="http://schemas.openxmlformats.org/drawingml/2006/main">
-            <a:pPr marL="0" indent="0">
+            <a:pPr marL="0" indent="0" algn="l">
               <a:buNone/>
             </a:pPr>
             <a:r>
@@ -5470,7 +5516,7 @@
           <p:cNvPr id="2" name="Image 0">
             <a:extLst xmlns:a="http://schemas.openxmlformats.org/drawingml/2006/main">
               <a:ext uri="{FF2B5EF4-FFF2-40B4-BE49-F238E27FC236}">
-                <a16:creationId xmlns:a16="http://schemas.microsoft.com/office/drawing/2014/main" id="{DFCE2412-6F85-40A7-B4A8-72A39BF5EFFE}"/>
+                <a16:creationId xmlns:a16="http://schemas.microsoft.com/office/drawing/2014/main" id="{55FAEDB6-D573-4C2E-9181-0633D8E0F617}"/>
               </a:ext>
             </a:extLst>
           </p:cNvPr>
@@ -5480,7 +5526,7 @@
           <p:nvPr/>
         </p:nvPicPr>
         <p:blipFill>
-          <a:blip xmlns:r="http://schemas.openxmlformats.org/officeDocument/2006/relationships" xmlns:a="http://schemas.openxmlformats.org/drawingml/2006/main" r:embed="R28b3cd3184614b64"/>
+          <a:blip xmlns:r="http://schemas.openxmlformats.org/officeDocument/2006/relationships" xmlns:a="http://schemas.openxmlformats.org/drawingml/2006/main" r:embed="R10e2260cf2e34af1"/>
           <a:srcRect xmlns:a="http://schemas.openxmlformats.org/drawingml/2006/main" l="0" t="0" r="0" b="0"/>
           <a:stretch xmlns:a="http://schemas.openxmlformats.org/drawingml/2006/main">
             <a:fillRect l="0" t="0" r="0" b="0"/>
@@ -5521,7 +5567,9 @@
           <a:noFill xmlns:a="http://schemas.openxmlformats.org/drawingml/2006/main"/>
         </p:spPr>
         <p:txBody>
-          <a:bodyPr xmlns:a="http://schemas.openxmlformats.org/drawingml/2006/main" wrap="square" lIns="0" tIns="0" rIns="0" bIns="0" anchor="ctr"/>
+          <a:bodyPr xmlns:a="http://schemas.openxmlformats.org/drawingml/2006/main" wrap="square" lIns="0" tIns="0" rIns="0" bIns="0" anchor="ctr">
+            <a:normAutofit fontScale="100000"/>
+          </a:bodyPr>
           <a:lstStyle xmlns:a="http://schemas.openxmlformats.org/drawingml/2006/main"/>
           <a:p xmlns:a="http://schemas.openxmlformats.org/drawingml/2006/main">
             <a:pPr marL="0" indent="0">
@@ -5559,7 +5607,7 @@
         <p:spPr>
           <a:xfrm xmlns:a="http://schemas.openxmlformats.org/drawingml/2006/main">
             <a:off x="612648" y="987552"/>
-            <a:ext cx="10698480" cy="310896"/>
+            <a:ext cx="9655302" cy="310896"/>
           </a:xfrm>
           <a:prstGeom xmlns:a="http://schemas.openxmlformats.org/drawingml/2006/main" prst="rect">
             <a:avLst/>
@@ -5567,7 +5615,9 @@
           <a:noFill xmlns:a="http://schemas.openxmlformats.org/drawingml/2006/main"/>
         </p:spPr>
         <p:txBody>
-          <a:bodyPr xmlns:a="http://schemas.openxmlformats.org/drawingml/2006/main" wrap="square" lIns="0" tIns="0" rIns="0" bIns="0" anchor="ctr"/>
+          <a:bodyPr xmlns:a="http://schemas.openxmlformats.org/drawingml/2006/main" wrap="square" lIns="0" tIns="0" rIns="0" bIns="0" anchor="ctr">
+            <a:normAutofit fontScale="100000"/>
+          </a:bodyPr>
           <a:lstStyle xmlns:a="http://schemas.openxmlformats.org/drawingml/2006/main"/>
           <a:p xmlns:a="http://schemas.openxmlformats.org/drawingml/2006/main">
             <a:pPr marL="0" indent="0">
@@ -5613,12 +5663,14 @@
           <a:noFill xmlns:a="http://schemas.openxmlformats.org/drawingml/2006/main"/>
         </p:spPr>
         <p:txBody>
-          <a:bodyPr xmlns:a="http://schemas.openxmlformats.org/drawingml/2006/main" wrap="square" lIns="635" tIns="635" rIns="635" bIns="635" anchor="ctr">
-            <a:normAutofit/>
+          <a:bodyPr xmlns:a="http://schemas.openxmlformats.org/drawingml/2006/main" wrap="square" lIns="0" tIns="0" rIns="0" bIns="0" anchor="t">
+            <a:normAutofit fontScale="100000"/>
           </a:bodyPr>
-          <a:lstStyle xmlns:a="http://schemas.openxmlformats.org/drawingml/2006/main"/>
-          <a:p xmlns:a="http://schemas.openxmlformats.org/drawingml/2006/main">
-            <a:pPr marL="254000" indent="-254000">
+          <a:lstStyle xmlns:a="http://schemas.openxmlformats.org/drawingml/2006/main">
+            <a:defPPr algn="l"/>
+          </a:lstStyle>
+          <a:p xmlns:a="http://schemas.openxmlformats.org/drawingml/2006/main">
+            <a:pPr marL="254000" indent="-254000" algn="l">
               <a:buSzPct val="100000"/>
               <a:buChar char="•"/>
             </a:pPr>
@@ -5636,7 +5688,7 @@
             <a:endParaRPr sz="2100"/>
           </a:p>
           <a:p xmlns:a="http://schemas.openxmlformats.org/drawingml/2006/main">
-            <a:pPr marL="254000" indent="-254000">
+            <a:pPr marL="254000" indent="-254000" algn="l">
               <a:buSzPct val="100000"/>
               <a:buChar char="•"/>
             </a:pPr>
@@ -5654,7 +5706,7 @@
             <a:endParaRPr sz="2100"/>
           </a:p>
           <a:p xmlns:a="http://schemas.openxmlformats.org/drawingml/2006/main">
-            <a:pPr marL="254000" indent="-254000">
+            <a:pPr marL="254000" indent="-254000" algn="l">
               <a:buSzPct val="100000"/>
               <a:buChar char="•"/>
             </a:pPr>
@@ -5672,7 +5724,7 @@
             <a:endParaRPr sz="2100"/>
           </a:p>
           <a:p xmlns:a="http://schemas.openxmlformats.org/drawingml/2006/main">
-            <a:pPr marL="254000" indent="-254000">
+            <a:pPr marL="254000" indent="-254000" algn="l">
               <a:buSzPct val="100000"/>
               <a:buChar char="•"/>
             </a:pPr>
@@ -5690,7 +5742,7 @@
             <a:endParaRPr sz="2100"/>
           </a:p>
           <a:p xmlns:a="http://schemas.openxmlformats.org/drawingml/2006/main">
-            <a:pPr marL="254000" indent="-254000">
+            <a:pPr marL="254000" indent="-254000" algn="l">
               <a:buSzPct val="100000"/>
               <a:buChar char="•"/>
             </a:pPr>
@@ -5861,7 +5913,7 @@
           <p:cNvPr id="2" name="Image 0">
             <a:extLst xmlns:a="http://schemas.openxmlformats.org/drawingml/2006/main">
               <a:ext uri="{FF2B5EF4-FFF2-40B4-BE49-F238E27FC236}">
-                <a16:creationId xmlns:a16="http://schemas.microsoft.com/office/drawing/2014/main" id="{53332FD9-5AE9-41DD-BAF2-D025CCF36BE5}"/>
+                <a16:creationId xmlns:a16="http://schemas.microsoft.com/office/drawing/2014/main" id="{F9555FD8-3EE3-4206-9E01-F54BD532CC7F}"/>
               </a:ext>
             </a:extLst>
           </p:cNvPr>
@@ -5871,7 +5923,7 @@
           <p:nvPr/>
         </p:nvPicPr>
         <p:blipFill>
-          <a:blip xmlns:r="http://schemas.openxmlformats.org/officeDocument/2006/relationships" xmlns:a="http://schemas.openxmlformats.org/drawingml/2006/main" r:embed="Rda1022ed53c34585"/>
+          <a:blip xmlns:r="http://schemas.openxmlformats.org/officeDocument/2006/relationships" xmlns:a="http://schemas.openxmlformats.org/drawingml/2006/main" r:embed="R94b252283f5f4a5b"/>
           <a:srcRect xmlns:a="http://schemas.openxmlformats.org/drawingml/2006/main" l="0" t="0" r="0" b="0"/>
           <a:stretch xmlns:a="http://schemas.openxmlformats.org/drawingml/2006/main">
             <a:fillRect l="0" t="0" r="0" b="0"/>
@@ -5912,7 +5964,9 @@
           <a:noFill xmlns:a="http://schemas.openxmlformats.org/drawingml/2006/main"/>
         </p:spPr>
         <p:txBody>
-          <a:bodyPr xmlns:a="http://schemas.openxmlformats.org/drawingml/2006/main" wrap="square" lIns="0" tIns="0" rIns="0" bIns="0" anchor="ctr"/>
+          <a:bodyPr xmlns:a="http://schemas.openxmlformats.org/drawingml/2006/main" wrap="square" lIns="0" tIns="0" rIns="0" bIns="0" anchor="ctr">
+            <a:normAutofit fontScale="100000"/>
+          </a:bodyPr>
           <a:lstStyle xmlns:a="http://schemas.openxmlformats.org/drawingml/2006/main"/>
           <a:p xmlns:a="http://schemas.openxmlformats.org/drawingml/2006/main">
             <a:pPr marL="0" indent="0">
@@ -5950,7 +6004,7 @@
         <p:spPr>
           <a:xfrm xmlns:a="http://schemas.openxmlformats.org/drawingml/2006/main">
             <a:off x="612648" y="987552"/>
-            <a:ext cx="10698480" cy="310896"/>
+            <a:ext cx="9655302" cy="310896"/>
           </a:xfrm>
           <a:prstGeom xmlns:a="http://schemas.openxmlformats.org/drawingml/2006/main" prst="rect">
             <a:avLst/>
@@ -5958,7 +6012,9 @@
           <a:noFill xmlns:a="http://schemas.openxmlformats.org/drawingml/2006/main"/>
         </p:spPr>
         <p:txBody>
-          <a:bodyPr xmlns:a="http://schemas.openxmlformats.org/drawingml/2006/main" wrap="square" lIns="0" tIns="0" rIns="0" bIns="0" anchor="ctr"/>
+          <a:bodyPr xmlns:a="http://schemas.openxmlformats.org/drawingml/2006/main" wrap="square" lIns="0" tIns="0" rIns="0" bIns="0" anchor="ctr">
+            <a:normAutofit fontScale="100000"/>
+          </a:bodyPr>
           <a:lstStyle xmlns:a="http://schemas.openxmlformats.org/drawingml/2006/main"/>
           <a:p xmlns:a="http://schemas.openxmlformats.org/drawingml/2006/main">
             <a:pPr marL="0" indent="0">
@@ -6080,32 +6136,34 @@
           <a:noFill xmlns:a="http://schemas.openxmlformats.org/drawingml/2006/main"/>
         </p:spPr>
         <p:txBody>
-          <a:bodyPr xmlns:a="http://schemas.openxmlformats.org/drawingml/2006/main" wrap="square" lIns="254" tIns="254" rIns="254" bIns="254" anchor="ctr">
-            <a:normAutofit/>
+          <a:bodyPr xmlns:a="http://schemas.openxmlformats.org/drawingml/2006/main" wrap="square" lIns="0" tIns="0" rIns="0" bIns="0" anchor="t">
+            <a:normAutofit fontScale="100000"/>
           </a:bodyPr>
-          <a:lstStyle xmlns:a="http://schemas.openxmlformats.org/drawingml/2006/main"/>
+          <a:lstStyle xmlns:a="http://schemas.openxmlformats.org/drawingml/2006/main">
+            <a:defPPr algn="l"/>
+          </a:lstStyle>
+          <a:p xmlns:a="http://schemas.openxmlformats.org/drawingml/2006/main">
+            <a:pPr marL="0" indent="0" algn="l">
+              <a:buNone/>
+            </a:pPr>
+            <a:r>
+              <a:rPr sz="1700">
+                <a:solidFill>
+                  <a:srgbClr val="595465"/>
+                </a:solidFill>
+              </a:rPr>
+              <a:t>Cloud database</a:t>
+            </a:r>
+            <a:endParaRPr sz="1700"/>
+          </a:p>
           <a:p xmlns:a="http://schemas.openxmlformats.org/drawingml/2006/main">
             <a:pPr marL="0" indent="0">
               <a:buNone/>
             </a:pPr>
-            <a:r>
-              <a:rPr sz="1700">
-                <a:solidFill>
-                  <a:srgbClr val="595465"/>
-                </a:solidFill>
-              </a:rPr>
-              <a:t>Cloud database</a:t>
-            </a:r>
             <a:endParaRPr sz="1700"/>
           </a:p>
           <a:p xmlns:a="http://schemas.openxmlformats.org/drawingml/2006/main">
-            <a:pPr marL="0" indent="0">
-              <a:buNone/>
-            </a:pPr>
-            <a:endParaRPr sz="1700"/>
-          </a:p>
-          <a:p xmlns:a="http://schemas.openxmlformats.org/drawingml/2006/main">
-            <a:pPr marL="0" indent="0">
+            <a:pPr marL="0" indent="0" algn="l">
               <a:buNone/>
             </a:pPr>
             <a:r>
@@ -6221,32 +6279,34 @@
           <a:noFill xmlns:a="http://schemas.openxmlformats.org/drawingml/2006/main"/>
         </p:spPr>
         <p:txBody>
-          <a:bodyPr xmlns:a="http://schemas.openxmlformats.org/drawingml/2006/main" wrap="square" lIns="254" tIns="254" rIns="254" bIns="254" anchor="ctr">
-            <a:normAutofit/>
+          <a:bodyPr xmlns:a="http://schemas.openxmlformats.org/drawingml/2006/main" wrap="square" lIns="0" tIns="0" rIns="0" bIns="0" anchor="t">
+            <a:normAutofit fontScale="100000"/>
           </a:bodyPr>
-          <a:lstStyle xmlns:a="http://schemas.openxmlformats.org/drawingml/2006/main"/>
+          <a:lstStyle xmlns:a="http://schemas.openxmlformats.org/drawingml/2006/main">
+            <a:defPPr algn="l"/>
+          </a:lstStyle>
+          <a:p xmlns:a="http://schemas.openxmlformats.org/drawingml/2006/main">
+            <a:pPr marL="0" indent="0" algn="l">
+              <a:buNone/>
+            </a:pPr>
+            <a:r>
+              <a:rPr sz="1700">
+                <a:solidFill>
+                  <a:srgbClr val="595465"/>
+                </a:solidFill>
+              </a:rPr>
+              <a:t>Backend hosting</a:t>
+            </a:r>
+            <a:endParaRPr sz="1700"/>
+          </a:p>
           <a:p xmlns:a="http://schemas.openxmlformats.org/drawingml/2006/main">
             <a:pPr marL="0" indent="0">
               <a:buNone/>
             </a:pPr>
-            <a:r>
-              <a:rPr sz="1700">
-                <a:solidFill>
-                  <a:srgbClr val="595465"/>
-                </a:solidFill>
-              </a:rPr>
-              <a:t>Backend hosting</a:t>
-            </a:r>
             <a:endParaRPr sz="1700"/>
           </a:p>
           <a:p xmlns:a="http://schemas.openxmlformats.org/drawingml/2006/main">
-            <a:pPr marL="0" indent="0">
-              <a:buNone/>
-            </a:pPr>
-            <a:endParaRPr sz="1700"/>
-          </a:p>
-          <a:p xmlns:a="http://schemas.openxmlformats.org/drawingml/2006/main">
-            <a:pPr marL="0" indent="0">
+            <a:pPr marL="0" indent="0" algn="l">
               <a:buNone/>
             </a:pPr>
             <a:r>
@@ -6362,32 +6422,34 @@
           <a:noFill xmlns:a="http://schemas.openxmlformats.org/drawingml/2006/main"/>
         </p:spPr>
         <p:txBody>
-          <a:bodyPr xmlns:a="http://schemas.openxmlformats.org/drawingml/2006/main" wrap="square" lIns="254" tIns="254" rIns="254" bIns="254" anchor="ctr">
-            <a:normAutofit/>
+          <a:bodyPr xmlns:a="http://schemas.openxmlformats.org/drawingml/2006/main" wrap="square" lIns="0" tIns="0" rIns="0" bIns="0" anchor="t">
+            <a:normAutofit fontScale="100000"/>
           </a:bodyPr>
-          <a:lstStyle xmlns:a="http://schemas.openxmlformats.org/drawingml/2006/main"/>
+          <a:lstStyle xmlns:a="http://schemas.openxmlformats.org/drawingml/2006/main">
+            <a:defPPr algn="l"/>
+          </a:lstStyle>
+          <a:p xmlns:a="http://schemas.openxmlformats.org/drawingml/2006/main">
+            <a:pPr marL="0" indent="0" algn="l">
+              <a:buNone/>
+            </a:pPr>
+            <a:r>
+              <a:rPr sz="1700">
+                <a:solidFill>
+                  <a:srgbClr val="595465"/>
+                </a:solidFill>
+              </a:rPr>
+              <a:t>Frontend hosting</a:t>
+            </a:r>
+            <a:endParaRPr sz="1700"/>
+          </a:p>
           <a:p xmlns:a="http://schemas.openxmlformats.org/drawingml/2006/main">
             <a:pPr marL="0" indent="0">
               <a:buNone/>
             </a:pPr>
-            <a:r>
-              <a:rPr sz="1700">
-                <a:solidFill>
-                  <a:srgbClr val="595465"/>
-                </a:solidFill>
-              </a:rPr>
-              <a:t>Frontend hosting</a:t>
-            </a:r>
             <a:endParaRPr sz="1700"/>
           </a:p>
           <a:p xmlns:a="http://schemas.openxmlformats.org/drawingml/2006/main">
-            <a:pPr marL="0" indent="0">
-              <a:buNone/>
-            </a:pPr>
-            <a:endParaRPr sz="1700"/>
-          </a:p>
-          <a:p xmlns:a="http://schemas.openxmlformats.org/drawingml/2006/main">
-            <a:pPr marL="0" indent="0">
+            <a:pPr marL="0" indent="0" algn="l">
               <a:buNone/>
             </a:pPr>
             <a:r>
@@ -6561,7 +6623,7 @@
           <p:cNvPr id="2" name="Image 0">
             <a:extLst xmlns:a="http://schemas.openxmlformats.org/drawingml/2006/main">
               <a:ext uri="{FF2B5EF4-FFF2-40B4-BE49-F238E27FC236}">
-                <a16:creationId xmlns:a16="http://schemas.microsoft.com/office/drawing/2014/main" id="{9FB5E200-042C-4B6C-8ED9-B5A06B0093E0}"/>
+                <a16:creationId xmlns:a16="http://schemas.microsoft.com/office/drawing/2014/main" id="{2B6B9232-4525-4E38-90AD-DAB65811CEB1}"/>
               </a:ext>
             </a:extLst>
           </p:cNvPr>
@@ -6571,7 +6633,7 @@
           <p:nvPr/>
         </p:nvPicPr>
         <p:blipFill>
-          <a:blip xmlns:r="http://schemas.openxmlformats.org/officeDocument/2006/relationships" xmlns:a="http://schemas.openxmlformats.org/drawingml/2006/main" r:embed="R2ee6ebee7b024f2c"/>
+          <a:blip xmlns:r="http://schemas.openxmlformats.org/officeDocument/2006/relationships" xmlns:a="http://schemas.openxmlformats.org/drawingml/2006/main" r:embed="Rcc539f751bef4714"/>
           <a:srcRect xmlns:a="http://schemas.openxmlformats.org/drawingml/2006/main" l="0" t="0" r="0" b="0"/>
           <a:stretch xmlns:a="http://schemas.openxmlformats.org/drawingml/2006/main">
             <a:fillRect l="0" t="0" r="0" b="0"/>
@@ -6835,7 +6897,7 @@
                 <a:latin typeface="Arial"/>
                 <a:ea typeface="Arial"/>
                 <a:cs typeface="Arial"/>
-                <a:hlinkClick xmlns:r="http://schemas.openxmlformats.org/officeDocument/2006/relationships" r:id="Rebbb747399fa47c5"/>
+                <a:hlinkClick xmlns:r="http://schemas.openxmlformats.org/officeDocument/2006/relationships" r:id="R7d139971a2c84a76"/>
               </a:rPr>
               <a:t>https://tech-it-and-go.onrender.com/equipment</a:t>
             </a:r>

</xml_diff>